<commit_message>
Remove RCM and version references from proposals and client report; unversioned file names
- Proposals (user's versions edited in place): controls referred to as the GT AI Risk Assessment
  Framework; no version numbers on GT tools or documents
- Client report and engine wording: controls of the GT AI Risk Assessment Framework (no RCM / v2.1)
- Toolkits, deck builders and app list updated to the same wording; report screenshots refreshed
- Files renamed: GT_AI_RCM.xlsx, GT_AI_Security_and_Agent_Audit_Checklist.xlsx,
  GT_AI_Risk_Assessment_Framework.docx

Co-Authored-By: Claude Opus 5.5 <noreply@anthropic.com>
Claude-Session: https://claude.ai/code/session_01X8ossW6xvKTGEs2GV44CxS
</commit_message>
<xml_diff>
--- a/02_AI_Strategy_and_Roadmap/GT_AI_Strategy_and_Roadmap_Proposal.pptx
+++ b/02_AI_Strategy_and_Roadmap/GT_AI_Strategy_and_Roadmap_Proposal.pptx
@@ -30568,7 +30568,7 @@
                 </a:solidFill>
                 <a:latin typeface="Arial"/>
               </a:rPr>
-              <a:t>AI policy, AI register, tier-based risk assessment, GT AI RCM v2.1 controls</a:t>
+              <a:t>AI policy, AI register, tier-based risk assessment and controls (GT AI Risk Assessment Framework)</a:t>
             </a:r>
           </a:p>
         </p:txBody>
@@ -32799,7 +32799,7 @@
                           </a:solidFill>
                           <a:latin typeface="Arial"/>
                         </a:rPr>
-                        <a:t>GT AI Risk Assessment Framework v1.1 and GT AI RCM v2.1</a:t>
+                        <a:t>GT AI Risk Assessment Framework</a:t>
                       </a:r>
                     </a:p>
                   </a:txBody>
@@ -37619,7 +37619,7 @@
                 </a:solidFill>
                 <a:latin typeface="Arial"/>
               </a:rPr>
-              <a:t>Audit, GRC and cyber heritage; Bahrain PDPL, CBB, iGA AI Policy and EU AI Act mapped into our AI RCM v2.1 (81 controls).</a:t>
+              <a:t>Audit, GRC and cyber heritage; Bahrain PDPL, CBB, iGA AI Policy and EU AI Act mapped into the GT AI Risk Assessment Framework.</a:t>
             </a:r>
           </a:p>
         </p:txBody>
@@ -37992,7 +37992,7 @@
                           </a:solidFill>
                           <a:latin typeface="Arial"/>
                         </a:rPr>
-                        <a:t>Available (v2.0)</a:t>
+                        <a:t>Available</a:t>
                       </a:r>
                     </a:p>
                   </a:txBody>
@@ -38043,7 +38043,7 @@
                           </a:solidFill>
                           <a:latin typeface="Arial"/>
                         </a:rPr>
-                        <a:t>Available (v2.0)</a:t>
+                        <a:t>Available</a:t>
                       </a:r>
                     </a:p>
                   </a:txBody>
@@ -38072,7 +38072,7 @@
                           </a:solidFill>
                           <a:latin typeface="Arial"/>
                         </a:rPr>
-                        <a:t>GT AI RCM v2.1 + AI Security &amp; Agent Audit Checklist</a:t>
+                        <a:t>GT AI Security &amp; Agent Audit Checklist</a:t>
                       </a:r>
                     </a:p>
                   </a:txBody>
@@ -38145,7 +38145,7 @@
                           </a:solidFill>
                           <a:latin typeface="Arial"/>
                         </a:rPr>
-                        <a:t>Available (v1.1)</a:t>
+                        <a:t>Available</a:t>
                       </a:r>
                     </a:p>
                   </a:txBody>

</xml_diff>

<commit_message>
Readiness proposal: three engagement durations with Gantt timelines; strategy formulation slide
- Readiness: Essential 5 working days, Standard 2 weeks, Plus 6 weeks (extendable to 8) with a
  Gantt timeline slide per option; Plus scope covers AI-system deep dives; related slides aligned
- Strategy: 'How We Formulate Your AI Strategy' (6 steps, client input and outputs, strategy on a
  page); client self-assessment portal removed from GT tools list
- src/update_proposals.py applies these in place to the user-edited decks; ops guide and README updated

Co-Authored-By: Claude Opus 5.5 <noreply@anthropic.com>
Claude-Session: https://claude.ai/code/session_01X8ossW6xvKTGEs2GV44CxS
</commit_message>
<xml_diff>
--- a/02_AI_Strategy_and_Roadmap/GT_AI_Strategy_and_Roadmap_Proposal.pptx
+++ b/02_AI_Strategy_and_Roadmap/GT_AI_Strategy_and_Roadmap_Proposal.pptx
@@ -27,6 +27,7 @@
     <p:sldId id="2141411907" r:id="rId21"/>
     <p:sldId id="2141411908" r:id="rId22"/>
     <p:sldId id="2141411909" r:id="rId23"/>
+    <p:sldId id="2141411918" r:id="rId39"/>
     <p:sldId id="2141411910" r:id="rId24"/>
     <p:sldId id="2141411911" r:id="rId25"/>
     <p:sldId id="2141411912" r:id="rId26"/>
@@ -37882,7 +37883,7 @@
         </p:nvGraphicFramePr>
         <p:xfrm>
           <a:off x="6230939" y="1810000"/>
-          <a:ext cx="5556542" cy="3040000"/>
+          <a:ext cx="5556542" cy="2660000"/>
         </p:xfrm>
         <a:graphic>
           <a:graphicData uri="http://schemas.openxmlformats.org/drawingml/2006/table">
@@ -38263,57 +38264,6 @@
                   </a:ext>
                 </a:extLst>
               </a:tr>
-              <a:tr h="380000">
-                <a:tc>
-                  <a:txBody>
-                    <a:bodyPr/>
-                    <a:lstStyle/>
-                    <a:p>
-                      <a:r>
-                        <a:rPr sz="950" b="1">
-                          <a:solidFill>
-                            <a:srgbClr val="222222"/>
-                          </a:solidFill>
-                          <a:latin typeface="Arial"/>
-                        </a:rPr>
-                        <a:t>Client AI self-assessment portal</a:t>
-                      </a:r>
-                    </a:p>
-                  </a:txBody>
-                  <a:tcPr marL="54864" marR="54864" marT="27432" marB="27432" anchor="ctr">
-                    <a:solidFill>
-                      <a:srgbClr val="FFFFFF"/>
-                    </a:solidFill>
-                  </a:tcPr>
-                </a:tc>
-                <a:tc>
-                  <a:txBody>
-                    <a:bodyPr/>
-                    <a:lstStyle/>
-                    <a:p>
-                      <a:r>
-                        <a:rPr sz="950" b="0">
-                          <a:solidFill>
-                            <a:srgbClr val="222222"/>
-                          </a:solidFill>
-                          <a:latin typeface="Arial"/>
-                        </a:rPr>
-                        <a:t>Planned</a:t>
-                      </a:r>
-                    </a:p>
-                  </a:txBody>
-                  <a:tcPr marL="54864" marR="54864" marT="27432" marB="27432" anchor="ctr">
-                    <a:solidFill>
-                      <a:srgbClr val="FFE699"/>
-                    </a:solidFill>
-                  </a:tcPr>
-                </a:tc>
-                <a:extLst>
-                  <a:ext uri="{0D108BD9-81ED-4DB2-BD59-A6C34878D82A}">
-                    <a16:rowId xmlns:a16="http://schemas.microsoft.com/office/drawing/2014/main" val="10007"/>
-                  </a:ext>
-                </a:extLst>
-              </a:tr>
             </a:tbl>
           </a:graphicData>
         </a:graphic>
@@ -38817,6 +38767,2288 @@
                 <a:cs typeface="+mn-cs"/>
               </a:rPr>
               <a:t>Thank You !</a:t>
+            </a:r>
+          </a:p>
+        </p:txBody>
+      </p:sp>
+    </p:spTree>
+  </p:cSld>
+  <p:clrMapOvr>
+    <a:masterClrMapping/>
+  </p:clrMapOvr>
+</p:sld>
+</file>
+
+<file path=ppt/slides/slide25.xml><?xml version="1.0" encoding="utf-8"?>
+<p:sld xmlns:a="http://schemas.openxmlformats.org/drawingml/2006/main" xmlns:p="http://schemas.openxmlformats.org/presentationml/2006/main" xmlns:r="http://schemas.openxmlformats.org/officeDocument/2006/relationships">
+  <p:cSld>
+    <p:spTree>
+      <p:nvGrpSpPr>
+        <p:cNvPr id="1" name=""/>
+        <p:cNvGrpSpPr/>
+        <p:nvPr/>
+      </p:nvGrpSpPr>
+      <p:grpSpPr/>
+      <p:sp>
+        <p:nvSpPr>
+          <p:cNvPr id="4" name="Copyright">
+            <a:extLst>
+              <a:ext uri="{FF2B5EF4-FFF2-40B4-BE49-F238E27FC236}">
+                <a16:creationId xmlns:a16="http://schemas.microsoft.com/office/drawing/2014/main" id="{3B4D22EA-6C3B-5382-574E-D2753BFD76A9}"/>
+              </a:ext>
+            </a:extLst>
+          </p:cNvPr>
+          <p:cNvSpPr txBox="1">
+            <a:spLocks noChangeArrowheads="1"/>
+          </p:cNvSpPr>
+          <p:nvPr/>
+        </p:nvSpPr>
+        <p:spPr bwMode="auto">
+          <a:xfrm>
+            <a:off x="8547100" y="6553498"/>
+            <a:ext cx="3216275" cy="246063"/>
+          </a:xfrm>
+          <a:prstGeom prst="rect">
+            <a:avLst/>
+          </a:prstGeom>
+          <a:noFill/>
+          <a:ln>
+            <a:noFill/>
+          </a:ln>
+        </p:spPr>
+        <p:txBody>
+          <a:bodyPr lIns="0" rIns="0" anchor="ctr"/>
+          <a:lstStyle>
+            <a:lvl1pPr>
+              <a:defRPr>
+                <a:solidFill>
+                  <a:schemeClr val="tx1"/>
+                </a:solidFill>
+                <a:latin typeface="Arial" panose="020B0604020202020204" pitchFamily="34" charset="0"/>
+              </a:defRPr>
+            </a:lvl1pPr>
+            <a:lvl2pPr marL="742950" indent="-285750">
+              <a:defRPr>
+                <a:solidFill>
+                  <a:schemeClr val="tx1"/>
+                </a:solidFill>
+                <a:latin typeface="Arial" panose="020B0604020202020204" pitchFamily="34" charset="0"/>
+              </a:defRPr>
+            </a:lvl2pPr>
+            <a:lvl3pPr marL="1143000" indent="-228600">
+              <a:defRPr>
+                <a:solidFill>
+                  <a:schemeClr val="tx1"/>
+                </a:solidFill>
+                <a:latin typeface="Arial" panose="020B0604020202020204" pitchFamily="34" charset="0"/>
+              </a:defRPr>
+            </a:lvl3pPr>
+            <a:lvl4pPr marL="1600200" indent="-228600">
+              <a:defRPr>
+                <a:solidFill>
+                  <a:schemeClr val="tx1"/>
+                </a:solidFill>
+                <a:latin typeface="Arial" panose="020B0604020202020204" pitchFamily="34" charset="0"/>
+              </a:defRPr>
+            </a:lvl4pPr>
+            <a:lvl5pPr marL="2057400" indent="-228600">
+              <a:defRPr>
+                <a:solidFill>
+                  <a:schemeClr val="tx1"/>
+                </a:solidFill>
+                <a:latin typeface="Arial" panose="020B0604020202020204" pitchFamily="34" charset="0"/>
+              </a:defRPr>
+            </a:lvl5pPr>
+            <a:lvl6pPr marL="2514600" indent="-228600" fontAlgn="base">
+              <a:spcBef>
+                <a:spcPct val="0"/>
+              </a:spcBef>
+              <a:spcAft>
+                <a:spcPct val="0"/>
+              </a:spcAft>
+              <a:defRPr>
+                <a:solidFill>
+                  <a:schemeClr val="tx1"/>
+                </a:solidFill>
+                <a:latin typeface="Arial" panose="020B0604020202020204" pitchFamily="34" charset="0"/>
+              </a:defRPr>
+            </a:lvl6pPr>
+            <a:lvl7pPr marL="2971800" indent="-228600" fontAlgn="base">
+              <a:spcBef>
+                <a:spcPct val="0"/>
+              </a:spcBef>
+              <a:spcAft>
+                <a:spcPct val="0"/>
+              </a:spcAft>
+              <a:defRPr>
+                <a:solidFill>
+                  <a:schemeClr val="tx1"/>
+                </a:solidFill>
+                <a:latin typeface="Arial" panose="020B0604020202020204" pitchFamily="34" charset="0"/>
+              </a:defRPr>
+            </a:lvl7pPr>
+            <a:lvl8pPr marL="3429000" indent="-228600" fontAlgn="base">
+              <a:spcBef>
+                <a:spcPct val="0"/>
+              </a:spcBef>
+              <a:spcAft>
+                <a:spcPct val="0"/>
+              </a:spcAft>
+              <a:defRPr>
+                <a:solidFill>
+                  <a:schemeClr val="tx1"/>
+                </a:solidFill>
+                <a:latin typeface="Arial" panose="020B0604020202020204" pitchFamily="34" charset="0"/>
+              </a:defRPr>
+            </a:lvl8pPr>
+            <a:lvl9pPr marL="3886200" indent="-228600" fontAlgn="base">
+              <a:spcBef>
+                <a:spcPct val="0"/>
+              </a:spcBef>
+              <a:spcAft>
+                <a:spcPct val="0"/>
+              </a:spcAft>
+              <a:defRPr>
+                <a:solidFill>
+                  <a:schemeClr val="tx1"/>
+                </a:solidFill>
+                <a:latin typeface="Arial" panose="020B0604020202020204" pitchFamily="34" charset="0"/>
+              </a:defRPr>
+            </a:lvl9pPr>
+          </a:lstStyle>
+          <a:p>
+            <a:pPr eaLnBrk="1" hangingPunct="1">
+              <a:defRPr/>
+            </a:pPr>
+            <a:r>
+              <a:rPr lang="en-US" altLang="en-US" sz="800" dirty="0"/>
+              <a:t>© 2026 Grant Thornton Bahrain. All rights reserved</a:t>
+            </a:r>
+            <a:endParaRPr lang="en-GB" altLang="en-US" sz="800" dirty="0"/>
+          </a:p>
+        </p:txBody>
+      </p:sp>
+      <p:cxnSp>
+        <p:nvCxnSpPr>
+          <p:cNvPr id="5" name="Straight Connector 4">
+            <a:extLst>
+              <a:ext uri="{FF2B5EF4-FFF2-40B4-BE49-F238E27FC236}">
+                <a16:creationId xmlns:a16="http://schemas.microsoft.com/office/drawing/2014/main" id="{01C0A6B9-45EB-DBF7-B946-D7EB6F9BC51B}"/>
+              </a:ext>
+            </a:extLst>
+          </p:cNvPr>
+          <p:cNvCxnSpPr/>
+          <p:nvPr/>
+        </p:nvCxnSpPr>
+        <p:spPr>
+          <a:xfrm>
+            <a:off x="8179318" y="6529686"/>
+            <a:ext cx="3502025" cy="0"/>
+          </a:xfrm>
+          <a:prstGeom prst="line">
+            <a:avLst/>
+          </a:prstGeom>
+          <a:ln w="19050" cap="rnd">
+            <a:solidFill>
+              <a:srgbClr val="4F2D7F"/>
+            </a:solidFill>
+          </a:ln>
+          <a:effectLst/>
+        </p:spPr>
+        <p:style>
+          <a:lnRef idx="2">
+            <a:schemeClr val="accent1"/>
+          </a:lnRef>
+          <a:fillRef idx="0">
+            <a:schemeClr val="accent1"/>
+          </a:fillRef>
+          <a:effectRef idx="1">
+            <a:schemeClr val="accent1"/>
+          </a:effectRef>
+          <a:fontRef idx="minor">
+            <a:schemeClr val="tx1"/>
+          </a:fontRef>
+        </p:style>
+      </p:cxnSp>
+      <p:sp>
+        <p:nvSpPr>
+          <p:cNvPr id="6" name="Slide Number Placeholder 1">
+            <a:extLst>
+              <a:ext uri="{FF2B5EF4-FFF2-40B4-BE49-F238E27FC236}">
+                <a16:creationId xmlns:a16="http://schemas.microsoft.com/office/drawing/2014/main" id="{A3B2A613-D3C6-D0DC-6B04-CDC625527585}"/>
+              </a:ext>
+            </a:extLst>
+          </p:cNvPr>
+          <p:cNvSpPr txBox="1">
+            <a:spLocks/>
+          </p:cNvSpPr>
+          <p:nvPr/>
+        </p:nvSpPr>
+        <p:spPr>
+          <a:xfrm>
+            <a:off x="8296275" y="6555086"/>
+            <a:ext cx="244475" cy="244475"/>
+          </a:xfrm>
+          <a:prstGeom prst="rect">
+            <a:avLst/>
+          </a:prstGeom>
+        </p:spPr>
+        <p:txBody>
+          <a:bodyPr vert="horz" lIns="0" tIns="0" rIns="0" bIns="0" rtlCol="0" anchor="ctr"/>
+          <a:lstStyle>
+            <a:defPPr>
+              <a:defRPr lang="en-US"/>
+            </a:defPPr>
+            <a:lvl1pPr marL="0" algn="l" defTabSz="914400" rtl="0" eaLnBrk="1" fontAlgn="auto" latinLnBrk="0" hangingPunct="1">
+              <a:spcBef>
+                <a:spcPts val="0"/>
+              </a:spcBef>
+              <a:spcAft>
+                <a:spcPts val="0"/>
+              </a:spcAft>
+              <a:defRPr lang="en-US" sz="800" b="1" kern="1200">
+                <a:solidFill>
+                  <a:srgbClr val="4F2D7F"/>
+                </a:solidFill>
+                <a:latin typeface="+mn-lt"/>
+                <a:ea typeface="+mn-ea"/>
+                <a:cs typeface="+mn-cs"/>
+              </a:defRPr>
+            </a:lvl1pPr>
+            <a:lvl2pPr marL="457200" algn="l" defTabSz="914400" rtl="0" eaLnBrk="1" latinLnBrk="0" hangingPunct="1">
+              <a:defRPr sz="1800" kern="1200">
+                <a:solidFill>
+                  <a:schemeClr val="tx1"/>
+                </a:solidFill>
+                <a:latin typeface="+mn-lt"/>
+                <a:ea typeface="+mn-ea"/>
+                <a:cs typeface="+mn-cs"/>
+              </a:defRPr>
+            </a:lvl2pPr>
+            <a:lvl3pPr marL="914400" algn="l" defTabSz="914400" rtl="0" eaLnBrk="1" latinLnBrk="0" hangingPunct="1">
+              <a:defRPr sz="1800" kern="1200">
+                <a:solidFill>
+                  <a:schemeClr val="tx1"/>
+                </a:solidFill>
+                <a:latin typeface="+mn-lt"/>
+                <a:ea typeface="+mn-ea"/>
+                <a:cs typeface="+mn-cs"/>
+              </a:defRPr>
+            </a:lvl3pPr>
+            <a:lvl4pPr marL="1371600" algn="l" defTabSz="914400" rtl="0" eaLnBrk="1" latinLnBrk="0" hangingPunct="1">
+              <a:defRPr sz="1800" kern="1200">
+                <a:solidFill>
+                  <a:schemeClr val="tx1"/>
+                </a:solidFill>
+                <a:latin typeface="+mn-lt"/>
+                <a:ea typeface="+mn-ea"/>
+                <a:cs typeface="+mn-cs"/>
+              </a:defRPr>
+            </a:lvl4pPr>
+            <a:lvl5pPr marL="1828800" algn="l" defTabSz="914400" rtl="0" eaLnBrk="1" latinLnBrk="0" hangingPunct="1">
+              <a:defRPr sz="1800" kern="1200">
+                <a:solidFill>
+                  <a:schemeClr val="tx1"/>
+                </a:solidFill>
+                <a:latin typeface="+mn-lt"/>
+                <a:ea typeface="+mn-ea"/>
+                <a:cs typeface="+mn-cs"/>
+              </a:defRPr>
+            </a:lvl5pPr>
+            <a:lvl6pPr marL="2286000" algn="l" defTabSz="914400" rtl="0" eaLnBrk="1" latinLnBrk="0" hangingPunct="1">
+              <a:defRPr sz="1800" kern="1200">
+                <a:solidFill>
+                  <a:schemeClr val="tx1"/>
+                </a:solidFill>
+                <a:latin typeface="+mn-lt"/>
+                <a:ea typeface="+mn-ea"/>
+                <a:cs typeface="+mn-cs"/>
+              </a:defRPr>
+            </a:lvl6pPr>
+            <a:lvl7pPr marL="2743200" algn="l" defTabSz="914400" rtl="0" eaLnBrk="1" latinLnBrk="0" hangingPunct="1">
+              <a:defRPr sz="1800" kern="1200">
+                <a:solidFill>
+                  <a:schemeClr val="tx1"/>
+                </a:solidFill>
+                <a:latin typeface="+mn-lt"/>
+                <a:ea typeface="+mn-ea"/>
+                <a:cs typeface="+mn-cs"/>
+              </a:defRPr>
+            </a:lvl7pPr>
+            <a:lvl8pPr marL="3200400" algn="l" defTabSz="914400" rtl="0" eaLnBrk="1" latinLnBrk="0" hangingPunct="1">
+              <a:defRPr sz="1800" kern="1200">
+                <a:solidFill>
+                  <a:schemeClr val="tx1"/>
+                </a:solidFill>
+                <a:latin typeface="+mn-lt"/>
+                <a:ea typeface="+mn-ea"/>
+                <a:cs typeface="+mn-cs"/>
+              </a:defRPr>
+            </a:lvl8pPr>
+            <a:lvl9pPr marL="3657600" algn="l" defTabSz="914400" rtl="0" eaLnBrk="1" latinLnBrk="0" hangingPunct="1">
+              <a:defRPr sz="1800" kern="1200">
+                <a:solidFill>
+                  <a:schemeClr val="tx1"/>
+                </a:solidFill>
+                <a:latin typeface="+mn-lt"/>
+                <a:ea typeface="+mn-ea"/>
+                <a:cs typeface="+mn-cs"/>
+              </a:defRPr>
+            </a:lvl9pPr>
+          </a:lstStyle>
+          <a:p>
+            <a:pPr>
+              <a:defRPr/>
+            </a:pPr>
+            <a:fld id="{ED42419B-EEFE-4EEC-87E4-D75541E4ADAF}" type="slidenum">
+              <a:rPr lang="en-GB" smtClean="0"/>
+              <a:pPr>
+                <a:defRPr/>
+              </a:pPr>
+              <a:t>17</a:t>
+            </a:fld>
+            <a:endParaRPr lang="en-GB" dirty="0"/>
+          </a:p>
+        </p:txBody>
+      </p:sp>
+      <p:pic>
+        <p:nvPicPr>
+          <p:cNvPr id="7" name="Picture 6" descr="Shape&#10;&#10;Description automatically generated with medium confidence">
+            <a:extLst>
+              <a:ext uri="{FF2B5EF4-FFF2-40B4-BE49-F238E27FC236}">
+                <a16:creationId xmlns:a16="http://schemas.microsoft.com/office/drawing/2014/main" id="{73C4E759-2976-C340-AC49-7D86E7CA1B45}"/>
+              </a:ext>
+            </a:extLst>
+          </p:cNvPr>
+          <p:cNvPicPr>
+            <a:picLocks noChangeAspect="1"/>
+          </p:cNvPicPr>
+          <p:nvPr/>
+        </p:nvPicPr>
+        <p:blipFill>
+          <a:blip r:embed="rId2"/>
+          <a:stretch>
+            <a:fillRect/>
+          </a:stretch>
+        </p:blipFill>
+        <p:spPr>
+          <a:xfrm>
+            <a:off x="11111023" y="6594029"/>
+            <a:ext cx="668633" cy="124502"/>
+          </a:xfrm>
+          <a:prstGeom prst="rect">
+            <a:avLst/>
+          </a:prstGeom>
+        </p:spPr>
+      </p:pic>
+      <p:sp>
+        <p:nvSpPr>
+          <p:cNvPr id="8" name="TextBox 7"/>
+          <p:cNvSpPr txBox="1"/>
+          <p:nvPr/>
+        </p:nvSpPr>
+        <p:spPr>
+          <a:xfrm>
+            <a:off x="524396" y="400000"/>
+            <a:ext cx="11263086" cy="560000"/>
+          </a:xfrm>
+          <a:prstGeom prst="rect">
+            <a:avLst/>
+          </a:prstGeom>
+          <a:noFill/>
+        </p:spPr>
+        <p:txBody>
+          <a:bodyPr wrap="square" anchor="t" lIns="45720" rIns="45720" tIns="22860" bIns="22860">
+            <a:spAutoFit/>
+          </a:bodyPr>
+          <a:lstStyle/>
+          <a:p>
+            <a:pPr algn="l">
+              <a:spcAft>
+                <a:spcPts val="200"/>
+              </a:spcAft>
+            </a:pPr>
+            <a:r>
+              <a:rPr sz="2600" b="1">
+                <a:solidFill>
+                  <a:srgbClr val="4F2D7F"/>
+                </a:solidFill>
+                <a:latin typeface="Arial"/>
+              </a:rPr>
+              <a:t>How We Formulate Your AI Strategy</a:t>
+            </a:r>
+          </a:p>
+        </p:txBody>
+      </p:sp>
+      <p:sp>
+        <p:nvSpPr>
+          <p:cNvPr id="9" name="TextBox 8"/>
+          <p:cNvSpPr txBox="1"/>
+          <p:nvPr/>
+        </p:nvSpPr>
+        <p:spPr>
+          <a:xfrm>
+            <a:off x="504396" y="930000"/>
+            <a:ext cx="11263086" cy="480000"/>
+          </a:xfrm>
+          <a:prstGeom prst="rect">
+            <a:avLst/>
+          </a:prstGeom>
+          <a:noFill/>
+        </p:spPr>
+        <p:txBody>
+          <a:bodyPr wrap="square" anchor="t" lIns="45720" rIns="45720" tIns="22860" bIns="22860">
+            <a:spAutoFit/>
+          </a:bodyPr>
+          <a:lstStyle/>
+          <a:p>
+            <a:pPr algn="l">
+              <a:spcAft>
+                <a:spcPts val="200"/>
+              </a:spcAft>
+            </a:pPr>
+            <a:r>
+              <a:rPr sz="1150" b="0">
+                <a:solidFill>
+                  <a:srgbClr val="595959"/>
+                </a:solidFill>
+                <a:latin typeface="Arial"/>
+              </a:rPr>
+              <a:t>Six steps on Days 3-5 turn the evidence (situational analysis, AI position and opportunity map) into a strategy leadership can approve.</a:t>
+            </a:r>
+          </a:p>
+        </p:txBody>
+      </p:sp>
+      <p:sp>
+        <p:nvSpPr>
+          <p:cNvPr id="10" name="Rectangle 9"/>
+          <p:cNvSpPr/>
+          <p:nvPr/>
+        </p:nvSpPr>
+        <p:spPr>
+          <a:xfrm>
+            <a:off x="524396" y="1360000"/>
+            <a:ext cx="1810514" cy="560000"/>
+          </a:xfrm>
+          <a:prstGeom prst="rect">
+            <a:avLst/>
+          </a:prstGeom>
+          <a:solidFill>
+            <a:srgbClr val="4F2D7F"/>
+          </a:solidFill>
+          <a:ln>
+            <a:noFill/>
+          </a:ln>
+          <a:effectLst/>
+        </p:spPr>
+        <p:style>
+          <a:lnRef idx="1">
+            <a:schemeClr val="accent1"/>
+          </a:lnRef>
+          <a:fillRef idx="3">
+            <a:schemeClr val="accent1"/>
+          </a:fillRef>
+          <a:effectRef idx="2">
+            <a:schemeClr val="accent1"/>
+          </a:effectRef>
+          <a:fontRef idx="minor">
+            <a:schemeClr val="lt1"/>
+          </a:fontRef>
+        </p:style>
+        <p:txBody>
+          <a:bodyPr rtlCol="0" anchor="ctr" wrap="square" lIns="64008" rIns="64008" tIns="36576" bIns="36576"/>
+          <a:lstStyle/>
+          <a:p>
+            <a:pPr algn="ctr"/>
+            <a:r>
+              <a:rPr sz="1100" b="1">
+                <a:solidFill>
+                  <a:srgbClr val="FFFFFF"/>
+                </a:solidFill>
+                <a:latin typeface="Arial"/>
+              </a:rPr>
+              <a:t>1  </a:t>
+            </a:r>
+            <a:r>
+              <a:rPr sz="1100" b="1">
+                <a:solidFill>
+                  <a:srgbClr val="FFFFFF"/>
+                </a:solidFill>
+                <a:latin typeface="Arial"/>
+              </a:rPr>
+              <a:t>Synthesise the evidence</a:t>
+            </a:r>
+          </a:p>
+        </p:txBody>
+      </p:sp>
+      <p:sp>
+        <p:nvSpPr>
+          <p:cNvPr id="11" name="Rectangle 10"/>
+          <p:cNvSpPr/>
+          <p:nvPr/>
+        </p:nvSpPr>
+        <p:spPr>
+          <a:xfrm>
+            <a:off x="524396" y="1920000"/>
+            <a:ext cx="1810514" cy="1650000"/>
+          </a:xfrm>
+          <a:prstGeom prst="rect">
+            <a:avLst/>
+          </a:prstGeom>
+          <a:solidFill>
+            <a:srgbClr val="EDE7F6"/>
+          </a:solidFill>
+          <a:ln>
+            <a:noFill/>
+          </a:ln>
+          <a:effectLst/>
+        </p:spPr>
+        <p:style>
+          <a:lnRef idx="1">
+            <a:schemeClr val="accent1"/>
+          </a:lnRef>
+          <a:fillRef idx="3">
+            <a:schemeClr val="accent1"/>
+          </a:fillRef>
+          <a:effectRef idx="2">
+            <a:schemeClr val="accent1"/>
+          </a:effectRef>
+          <a:fontRef idx="minor">
+            <a:schemeClr val="lt1"/>
+          </a:fontRef>
+        </p:style>
+        <p:txBody>
+          <a:bodyPr rtlCol="0" anchor="t" wrap="square" lIns="64008" rIns="64008" tIns="36576" bIns="36576"/>
+          <a:lstStyle/>
+          <a:p>
+            <a:pPr algn="l"/>
+            <a:r>
+              <a:rPr sz="950" b="0">
+                <a:solidFill>
+                  <a:srgbClr val="222222"/>
+                </a:solidFill>
+                <a:latin typeface="Arial"/>
+              </a:rPr>
+              <a:t>Combine the situational analysis, AI position archetype and opportunity map into 4-6 strategic themes and options.</a:t>
+            </a:r>
+          </a:p>
+        </p:txBody>
+      </p:sp>
+      <p:sp>
+        <p:nvSpPr>
+          <p:cNvPr id="12" name="Rectangle 11"/>
+          <p:cNvSpPr/>
+          <p:nvPr/>
+        </p:nvSpPr>
+        <p:spPr>
+          <a:xfrm>
+            <a:off x="524396" y="3600000"/>
+            <a:ext cx="1810514" cy="520000"/>
+          </a:xfrm>
+          <a:prstGeom prst="rect">
+            <a:avLst/>
+          </a:prstGeom>
+          <a:solidFill>
+            <a:srgbClr val="FFFFFF"/>
+          </a:solidFill>
+          <a:ln w="12700">
+            <a:solidFill>
+              <a:srgbClr val="D9CCEB"/>
+            </a:solidFill>
+          </a:ln>
+          <a:effectLst/>
+        </p:spPr>
+        <p:style>
+          <a:lnRef idx="1">
+            <a:schemeClr val="accent1"/>
+          </a:lnRef>
+          <a:fillRef idx="3">
+            <a:schemeClr val="accent1"/>
+          </a:fillRef>
+          <a:effectRef idx="2">
+            <a:schemeClr val="accent1"/>
+          </a:effectRef>
+          <a:fontRef idx="minor">
+            <a:schemeClr val="lt1"/>
+          </a:fontRef>
+        </p:style>
+        <p:txBody>
+          <a:bodyPr rtlCol="0" anchor="ctr" wrap="square" lIns="64008" rIns="64008" tIns="36576" bIns="36576"/>
+          <a:lstStyle/>
+          <a:p>
+            <a:pPr algn="l"/>
+            <a:r>
+              <a:rPr sz="850" b="1">
+                <a:solidFill>
+                  <a:srgbClr val="4F2D7F"/>
+                </a:solidFill>
+                <a:latin typeface="Arial"/>
+              </a:rPr>
+              <a:t>Client: </a:t>
+            </a:r>
+            <a:r>
+              <a:rPr sz="850" b="0">
+                <a:solidFill>
+                  <a:srgbClr val="4F2D7F"/>
+                </a:solidFill>
+                <a:latin typeface="Arial"/>
+              </a:rPr>
+              <a:t>Sponsor review call</a:t>
+            </a:r>
+          </a:p>
+        </p:txBody>
+      </p:sp>
+      <p:sp>
+        <p:nvSpPr>
+          <p:cNvPr id="13" name="Rectangle 12"/>
+          <p:cNvSpPr/>
+          <p:nvPr/>
+        </p:nvSpPr>
+        <p:spPr>
+          <a:xfrm>
+            <a:off x="524396" y="4150000"/>
+            <a:ext cx="1810514" cy="520000"/>
+          </a:xfrm>
+          <a:prstGeom prst="rect">
+            <a:avLst/>
+          </a:prstGeom>
+          <a:solidFill>
+            <a:srgbClr val="D9CCEB"/>
+          </a:solidFill>
+          <a:ln>
+            <a:noFill/>
+          </a:ln>
+          <a:effectLst/>
+        </p:spPr>
+        <p:style>
+          <a:lnRef idx="1">
+            <a:schemeClr val="accent1"/>
+          </a:lnRef>
+          <a:fillRef idx="3">
+            <a:schemeClr val="accent1"/>
+          </a:fillRef>
+          <a:effectRef idx="2">
+            <a:schemeClr val="accent1"/>
+          </a:effectRef>
+          <a:fontRef idx="minor">
+            <a:schemeClr val="lt1"/>
+          </a:fontRef>
+        </p:style>
+        <p:txBody>
+          <a:bodyPr rtlCol="0" anchor="ctr" wrap="square" lIns="64008" rIns="64008" tIns="36576" bIns="36576"/>
+          <a:lstStyle/>
+          <a:p>
+            <a:pPr algn="l"/>
+            <a:r>
+              <a:rPr sz="900" b="1">
+                <a:solidFill>
+                  <a:srgbClr val="4F2D7F"/>
+                </a:solidFill>
+                <a:latin typeface="Arial"/>
+              </a:rPr>
+              <a:t>Output: </a:t>
+            </a:r>
+            <a:r>
+              <a:rPr sz="900" b="0">
+                <a:solidFill>
+                  <a:srgbClr val="4F2D7F"/>
+                </a:solidFill>
+                <a:latin typeface="Arial"/>
+              </a:rPr>
+              <a:t>Themes &amp; options</a:t>
+            </a:r>
+          </a:p>
+        </p:txBody>
+      </p:sp>
+      <p:sp>
+        <p:nvSpPr>
+          <p:cNvPr id="14" name="Rectangle 13"/>
+          <p:cNvSpPr/>
+          <p:nvPr/>
+        </p:nvSpPr>
+        <p:spPr>
+          <a:xfrm>
+            <a:off x="2414910" y="1360000"/>
+            <a:ext cx="1810514" cy="560000"/>
+          </a:xfrm>
+          <a:prstGeom prst="rect">
+            <a:avLst/>
+          </a:prstGeom>
+          <a:solidFill>
+            <a:srgbClr val="7B5BA6"/>
+          </a:solidFill>
+          <a:ln>
+            <a:noFill/>
+          </a:ln>
+          <a:effectLst/>
+        </p:spPr>
+        <p:style>
+          <a:lnRef idx="1">
+            <a:schemeClr val="accent1"/>
+          </a:lnRef>
+          <a:fillRef idx="3">
+            <a:schemeClr val="accent1"/>
+          </a:fillRef>
+          <a:effectRef idx="2">
+            <a:schemeClr val="accent1"/>
+          </a:effectRef>
+          <a:fontRef idx="minor">
+            <a:schemeClr val="lt1"/>
+          </a:fontRef>
+        </p:style>
+        <p:txBody>
+          <a:bodyPr rtlCol="0" anchor="ctr" wrap="square" lIns="64008" rIns="64008" tIns="36576" bIns="36576"/>
+          <a:lstStyle/>
+          <a:p>
+            <a:pPr algn="ctr"/>
+            <a:r>
+              <a:rPr sz="1100" b="1">
+                <a:solidFill>
+                  <a:srgbClr val="FFFFFF"/>
+                </a:solidFill>
+                <a:latin typeface="Arial"/>
+              </a:rPr>
+              <a:t>2  </a:t>
+            </a:r>
+            <a:r>
+              <a:rPr sz="1100" b="1">
+                <a:solidFill>
+                  <a:srgbClr val="FFFFFF"/>
+                </a:solidFill>
+                <a:latin typeface="Arial"/>
+              </a:rPr>
+              <a:t>Set the ambition</a:t>
+            </a:r>
+          </a:p>
+        </p:txBody>
+      </p:sp>
+      <p:sp>
+        <p:nvSpPr>
+          <p:cNvPr id="15" name="Rectangle 14"/>
+          <p:cNvSpPr/>
+          <p:nvPr/>
+        </p:nvSpPr>
+        <p:spPr>
+          <a:xfrm>
+            <a:off x="2414910" y="1920000"/>
+            <a:ext cx="1810514" cy="1650000"/>
+          </a:xfrm>
+          <a:prstGeom prst="rect">
+            <a:avLst/>
+          </a:prstGeom>
+          <a:solidFill>
+            <a:srgbClr val="EDE7F6"/>
+          </a:solidFill>
+          <a:ln>
+            <a:noFill/>
+          </a:ln>
+          <a:effectLst/>
+        </p:spPr>
+        <p:style>
+          <a:lnRef idx="1">
+            <a:schemeClr val="accent1"/>
+          </a:lnRef>
+          <a:fillRef idx="3">
+            <a:schemeClr val="accent1"/>
+          </a:fillRef>
+          <a:effectRef idx="2">
+            <a:schemeClr val="accent1"/>
+          </a:effectRef>
+          <a:fontRef idx="minor">
+            <a:schemeClr val="lt1"/>
+          </a:fontRef>
+        </p:style>
+        <p:txBody>
+          <a:bodyPr rtlCol="0" anchor="t" wrap="square" lIns="64008" rIns="64008" tIns="36576" bIns="36576"/>
+          <a:lstStyle/>
+          <a:p>
+            <a:pPr algn="l"/>
+            <a:r>
+              <a:rPr sz="950" b="0">
+                <a:solidFill>
+                  <a:srgbClr val="222222"/>
+                </a:solidFill>
+                <a:latin typeface="Arial"/>
+              </a:rPr>
+              <a:t>Leadership chooses the ambition level that fits the archetype - automate first, adopt &amp; configure, or build &amp; scale - and where AI will not be used.</a:t>
+            </a:r>
+          </a:p>
+        </p:txBody>
+      </p:sp>
+      <p:sp>
+        <p:nvSpPr>
+          <p:cNvPr id="16" name="Rectangle 15"/>
+          <p:cNvSpPr/>
+          <p:nvPr/>
+        </p:nvSpPr>
+        <p:spPr>
+          <a:xfrm>
+            <a:off x="2414910" y="3600000"/>
+            <a:ext cx="1810514" cy="520000"/>
+          </a:xfrm>
+          <a:prstGeom prst="rect">
+            <a:avLst/>
+          </a:prstGeom>
+          <a:solidFill>
+            <a:srgbClr val="FFFFFF"/>
+          </a:solidFill>
+          <a:ln w="12700">
+            <a:solidFill>
+              <a:srgbClr val="D9CCEB"/>
+            </a:solidFill>
+          </a:ln>
+          <a:effectLst/>
+        </p:spPr>
+        <p:style>
+          <a:lnRef idx="1">
+            <a:schemeClr val="accent1"/>
+          </a:lnRef>
+          <a:fillRef idx="3">
+            <a:schemeClr val="accent1"/>
+          </a:fillRef>
+          <a:effectRef idx="2">
+            <a:schemeClr val="accent1"/>
+          </a:effectRef>
+          <a:fontRef idx="minor">
+            <a:schemeClr val="lt1"/>
+          </a:fontRef>
+        </p:style>
+        <p:txBody>
+          <a:bodyPr rtlCol="0" anchor="ctr" wrap="square" lIns="64008" rIns="64008" tIns="36576" bIns="36576"/>
+          <a:lstStyle/>
+          <a:p>
+            <a:pPr algn="l"/>
+            <a:r>
+              <a:rPr sz="850" b="1">
+                <a:solidFill>
+                  <a:srgbClr val="4F2D7F"/>
+                </a:solidFill>
+                <a:latin typeface="Arial"/>
+              </a:rPr>
+              <a:t>Client: </a:t>
+            </a:r>
+            <a:r>
+              <a:rPr sz="850" b="0">
+                <a:solidFill>
+                  <a:srgbClr val="4F2D7F"/>
+                </a:solidFill>
+                <a:latin typeface="Arial"/>
+              </a:rPr>
+              <a:t>2-hour leadership workshop (Day 4)</a:t>
+            </a:r>
+          </a:p>
+        </p:txBody>
+      </p:sp>
+      <p:sp>
+        <p:nvSpPr>
+          <p:cNvPr id="17" name="Rectangle 16"/>
+          <p:cNvSpPr/>
+          <p:nvPr/>
+        </p:nvSpPr>
+        <p:spPr>
+          <a:xfrm>
+            <a:off x="2414910" y="4150000"/>
+            <a:ext cx="1810514" cy="520000"/>
+          </a:xfrm>
+          <a:prstGeom prst="rect">
+            <a:avLst/>
+          </a:prstGeom>
+          <a:solidFill>
+            <a:srgbClr val="D9CCEB"/>
+          </a:solidFill>
+          <a:ln>
+            <a:noFill/>
+          </a:ln>
+          <a:effectLst/>
+        </p:spPr>
+        <p:style>
+          <a:lnRef idx="1">
+            <a:schemeClr val="accent1"/>
+          </a:lnRef>
+          <a:fillRef idx="3">
+            <a:schemeClr val="accent1"/>
+          </a:fillRef>
+          <a:effectRef idx="2">
+            <a:schemeClr val="accent1"/>
+          </a:effectRef>
+          <a:fontRef idx="minor">
+            <a:schemeClr val="lt1"/>
+          </a:fontRef>
+        </p:style>
+        <p:txBody>
+          <a:bodyPr rtlCol="0" anchor="ctr" wrap="square" lIns="64008" rIns="64008" tIns="36576" bIns="36576"/>
+          <a:lstStyle/>
+          <a:p>
+            <a:pPr algn="l"/>
+            <a:r>
+              <a:rPr sz="900" b="1">
+                <a:solidFill>
+                  <a:srgbClr val="4F2D7F"/>
+                </a:solidFill>
+                <a:latin typeface="Arial"/>
+              </a:rPr>
+              <a:t>Output: </a:t>
+            </a:r>
+            <a:r>
+              <a:rPr sz="900" b="0">
+                <a:solidFill>
+                  <a:srgbClr val="4F2D7F"/>
+                </a:solidFill>
+                <a:latin typeface="Arial"/>
+              </a:rPr>
+              <a:t>AI vision &amp; ambition</a:t>
+            </a:r>
+          </a:p>
+        </p:txBody>
+      </p:sp>
+      <p:sp>
+        <p:nvSpPr>
+          <p:cNvPr id="18" name="Rectangle 17"/>
+          <p:cNvSpPr/>
+          <p:nvPr/>
+        </p:nvSpPr>
+        <p:spPr>
+          <a:xfrm>
+            <a:off x="4305424" y="1360000"/>
+            <a:ext cx="1810514" cy="560000"/>
+          </a:xfrm>
+          <a:prstGeom prst="rect">
+            <a:avLst/>
+          </a:prstGeom>
+          <a:solidFill>
+            <a:srgbClr val="00A7B5"/>
+          </a:solidFill>
+          <a:ln>
+            <a:noFill/>
+          </a:ln>
+          <a:effectLst/>
+        </p:spPr>
+        <p:style>
+          <a:lnRef idx="1">
+            <a:schemeClr val="accent1"/>
+          </a:lnRef>
+          <a:fillRef idx="3">
+            <a:schemeClr val="accent1"/>
+          </a:fillRef>
+          <a:effectRef idx="2">
+            <a:schemeClr val="accent1"/>
+          </a:effectRef>
+          <a:fontRef idx="minor">
+            <a:schemeClr val="lt1"/>
+          </a:fontRef>
+        </p:style>
+        <p:txBody>
+          <a:bodyPr rtlCol="0" anchor="ctr" wrap="square" lIns="64008" rIns="64008" tIns="36576" bIns="36576"/>
+          <a:lstStyle/>
+          <a:p>
+            <a:pPr algn="ctr"/>
+            <a:r>
+              <a:rPr sz="1100" b="1">
+                <a:solidFill>
+                  <a:srgbClr val="FFFFFF"/>
+                </a:solidFill>
+                <a:latin typeface="Arial"/>
+              </a:rPr>
+              <a:t>3  </a:t>
+            </a:r>
+            <a:r>
+              <a:rPr sz="1100" b="1">
+                <a:solidFill>
+                  <a:srgbClr val="FFFFFF"/>
+                </a:solidFill>
+                <a:latin typeface="Arial"/>
+              </a:rPr>
+              <a:t>Define objectives &amp; KPIs</a:t>
+            </a:r>
+          </a:p>
+        </p:txBody>
+      </p:sp>
+      <p:sp>
+        <p:nvSpPr>
+          <p:cNvPr id="19" name="Rectangle 18"/>
+          <p:cNvSpPr/>
+          <p:nvPr/>
+        </p:nvSpPr>
+        <p:spPr>
+          <a:xfrm>
+            <a:off x="4305424" y="1920000"/>
+            <a:ext cx="1810514" cy="1650000"/>
+          </a:xfrm>
+          <a:prstGeom prst="rect">
+            <a:avLst/>
+          </a:prstGeom>
+          <a:solidFill>
+            <a:srgbClr val="EDE7F6"/>
+          </a:solidFill>
+          <a:ln>
+            <a:noFill/>
+          </a:ln>
+          <a:effectLst/>
+        </p:spPr>
+        <p:style>
+          <a:lnRef idx="1">
+            <a:schemeClr val="accent1"/>
+          </a:lnRef>
+          <a:fillRef idx="3">
+            <a:schemeClr val="accent1"/>
+          </a:fillRef>
+          <a:effectRef idx="2">
+            <a:schemeClr val="accent1"/>
+          </a:effectRef>
+          <a:fontRef idx="minor">
+            <a:schemeClr val="lt1"/>
+          </a:fontRef>
+        </p:style>
+        <p:txBody>
+          <a:bodyPr rtlCol="0" anchor="t" wrap="square" lIns="64008" rIns="64008" tIns="36576" bIns="36576"/>
+          <a:lstStyle/>
+          <a:p>
+            <a:pPr algn="l"/>
+            <a:r>
+              <a:rPr sz="950" b="0">
+                <a:solidFill>
+                  <a:srgbClr val="222222"/>
+                </a:solidFill>
+                <a:latin typeface="Arial"/>
+              </a:rPr>
+              <a:t>3-5 measurable objectives with baselines and targets (hours released, cycle time, quality, customer, risk) from the library KPIs.</a:t>
+            </a:r>
+          </a:p>
+        </p:txBody>
+      </p:sp>
+      <p:sp>
+        <p:nvSpPr>
+          <p:cNvPr id="20" name="Rectangle 19"/>
+          <p:cNvSpPr/>
+          <p:nvPr/>
+        </p:nvSpPr>
+        <p:spPr>
+          <a:xfrm>
+            <a:off x="4305424" y="3600000"/>
+            <a:ext cx="1810514" cy="520000"/>
+          </a:xfrm>
+          <a:prstGeom prst="rect">
+            <a:avLst/>
+          </a:prstGeom>
+          <a:solidFill>
+            <a:srgbClr val="FFFFFF"/>
+          </a:solidFill>
+          <a:ln w="12700">
+            <a:solidFill>
+              <a:srgbClr val="D9CCEB"/>
+            </a:solidFill>
+          </a:ln>
+          <a:effectLst/>
+        </p:spPr>
+        <p:style>
+          <a:lnRef idx="1">
+            <a:schemeClr val="accent1"/>
+          </a:lnRef>
+          <a:fillRef idx="3">
+            <a:schemeClr val="accent1"/>
+          </a:fillRef>
+          <a:effectRef idx="2">
+            <a:schemeClr val="accent1"/>
+          </a:effectRef>
+          <a:fontRef idx="minor">
+            <a:schemeClr val="lt1"/>
+          </a:fontRef>
+        </p:style>
+        <p:txBody>
+          <a:bodyPr rtlCol="0" anchor="ctr" wrap="square" lIns="64008" rIns="64008" tIns="36576" bIns="36576"/>
+          <a:lstStyle/>
+          <a:p>
+            <a:pPr algn="l"/>
+            <a:r>
+              <a:rPr sz="850" b="1">
+                <a:solidFill>
+                  <a:srgbClr val="4F2D7F"/>
+                </a:solidFill>
+                <a:latin typeface="Arial"/>
+              </a:rPr>
+              <a:t>Client: </a:t>
+            </a:r>
+            <a:r>
+              <a:rPr sz="850" b="0">
+                <a:solidFill>
+                  <a:srgbClr val="4F2D7F"/>
+                </a:solidFill>
+                <a:latin typeface="Arial"/>
+              </a:rPr>
+              <a:t>Finance / business owners confirm baselines</a:t>
+            </a:r>
+          </a:p>
+        </p:txBody>
+      </p:sp>
+      <p:sp>
+        <p:nvSpPr>
+          <p:cNvPr id="21" name="Rectangle 20"/>
+          <p:cNvSpPr/>
+          <p:nvPr/>
+        </p:nvSpPr>
+        <p:spPr>
+          <a:xfrm>
+            <a:off x="4305424" y="4150000"/>
+            <a:ext cx="1810514" cy="520000"/>
+          </a:xfrm>
+          <a:prstGeom prst="rect">
+            <a:avLst/>
+          </a:prstGeom>
+          <a:solidFill>
+            <a:srgbClr val="D9CCEB"/>
+          </a:solidFill>
+          <a:ln>
+            <a:noFill/>
+          </a:ln>
+          <a:effectLst/>
+        </p:spPr>
+        <p:style>
+          <a:lnRef idx="1">
+            <a:schemeClr val="accent1"/>
+          </a:lnRef>
+          <a:fillRef idx="3">
+            <a:schemeClr val="accent1"/>
+          </a:fillRef>
+          <a:effectRef idx="2">
+            <a:schemeClr val="accent1"/>
+          </a:effectRef>
+          <a:fontRef idx="minor">
+            <a:schemeClr val="lt1"/>
+          </a:fontRef>
+        </p:style>
+        <p:txBody>
+          <a:bodyPr rtlCol="0" anchor="ctr" wrap="square" lIns="64008" rIns="64008" tIns="36576" bIns="36576"/>
+          <a:lstStyle/>
+          <a:p>
+            <a:pPr algn="l"/>
+            <a:r>
+              <a:rPr sz="900" b="1">
+                <a:solidFill>
+                  <a:srgbClr val="4F2D7F"/>
+                </a:solidFill>
+                <a:latin typeface="Arial"/>
+              </a:rPr>
+              <a:t>Output: </a:t>
+            </a:r>
+            <a:r>
+              <a:rPr sz="900" b="0">
+                <a:solidFill>
+                  <a:srgbClr val="4F2D7F"/>
+                </a:solidFill>
+                <a:latin typeface="Arial"/>
+              </a:rPr>
+              <a:t>Objectives &amp; KPI set</a:t>
+            </a:r>
+          </a:p>
+        </p:txBody>
+      </p:sp>
+      <p:sp>
+        <p:nvSpPr>
+          <p:cNvPr id="22" name="Rectangle 21"/>
+          <p:cNvSpPr/>
+          <p:nvPr/>
+        </p:nvSpPr>
+        <p:spPr>
+          <a:xfrm>
+            <a:off x="6195938" y="1360000"/>
+            <a:ext cx="1810514" cy="560000"/>
+          </a:xfrm>
+          <a:prstGeom prst="rect">
+            <a:avLst/>
+          </a:prstGeom>
+          <a:solidFill>
+            <a:srgbClr val="2E1A47"/>
+          </a:solidFill>
+          <a:ln>
+            <a:noFill/>
+          </a:ln>
+          <a:effectLst/>
+        </p:spPr>
+        <p:style>
+          <a:lnRef idx="1">
+            <a:schemeClr val="accent1"/>
+          </a:lnRef>
+          <a:fillRef idx="3">
+            <a:schemeClr val="accent1"/>
+          </a:fillRef>
+          <a:effectRef idx="2">
+            <a:schemeClr val="accent1"/>
+          </a:effectRef>
+          <a:fontRef idx="minor">
+            <a:schemeClr val="lt1"/>
+          </a:fontRef>
+        </p:style>
+        <p:txBody>
+          <a:bodyPr rtlCol="0" anchor="ctr" wrap="square" lIns="64008" rIns="64008" tIns="36576" bIns="36576"/>
+          <a:lstStyle/>
+          <a:p>
+            <a:pPr algn="ctr"/>
+            <a:r>
+              <a:rPr sz="1100" b="1">
+                <a:solidFill>
+                  <a:srgbClr val="FFFFFF"/>
+                </a:solidFill>
+                <a:latin typeface="Arial"/>
+              </a:rPr>
+              <a:t>4  </a:t>
+            </a:r>
+            <a:r>
+              <a:rPr sz="1100" b="1">
+                <a:solidFill>
+                  <a:srgbClr val="FFFFFF"/>
+                </a:solidFill>
+                <a:latin typeface="Arial"/>
+              </a:rPr>
+              <a:t>Shape the portfolio</a:t>
+            </a:r>
+          </a:p>
+        </p:txBody>
+      </p:sp>
+      <p:sp>
+        <p:nvSpPr>
+          <p:cNvPr id="23" name="Rectangle 22"/>
+          <p:cNvSpPr/>
+          <p:nvPr/>
+        </p:nvSpPr>
+        <p:spPr>
+          <a:xfrm>
+            <a:off x="6195938" y="1920000"/>
+            <a:ext cx="1810514" cy="1650000"/>
+          </a:xfrm>
+          <a:prstGeom prst="rect">
+            <a:avLst/>
+          </a:prstGeom>
+          <a:solidFill>
+            <a:srgbClr val="EDE7F6"/>
+          </a:solidFill>
+          <a:ln>
+            <a:noFill/>
+          </a:ln>
+          <a:effectLst/>
+        </p:spPr>
+        <p:style>
+          <a:lnRef idx="1">
+            <a:schemeClr val="accent1"/>
+          </a:lnRef>
+          <a:fillRef idx="3">
+            <a:schemeClr val="accent1"/>
+          </a:fillRef>
+          <a:effectRef idx="2">
+            <a:schemeClr val="accent1"/>
+          </a:effectRef>
+          <a:fontRef idx="minor">
+            <a:schemeClr val="lt1"/>
+          </a:fontRef>
+        </p:style>
+        <p:txBody>
+          <a:bodyPr rtlCol="0" anchor="t" wrap="square" lIns="64008" rIns="64008" tIns="36576" bIns="36576"/>
+          <a:lstStyle/>
+          <a:p>
+            <a:pPr algn="l"/>
+            <a:r>
+              <a:rPr sz="950" b="0">
+                <a:solidFill>
+                  <a:srgbClr val="222222"/>
+                </a:solidFill>
+                <a:latin typeface="Arial"/>
+              </a:rPr>
+              <a:t>Group ranked opportunities into an automation programme and an AI programme; decide build / buy / partner; size effort and benefits.</a:t>
+            </a:r>
+          </a:p>
+        </p:txBody>
+      </p:sp>
+      <p:sp>
+        <p:nvSpPr>
+          <p:cNvPr id="24" name="Rectangle 23"/>
+          <p:cNvSpPr/>
+          <p:nvPr/>
+        </p:nvSpPr>
+        <p:spPr>
+          <a:xfrm>
+            <a:off x="6195938" y="3600000"/>
+            <a:ext cx="1810514" cy="520000"/>
+          </a:xfrm>
+          <a:prstGeom prst="rect">
+            <a:avLst/>
+          </a:prstGeom>
+          <a:solidFill>
+            <a:srgbClr val="FFFFFF"/>
+          </a:solidFill>
+          <a:ln w="12700">
+            <a:solidFill>
+              <a:srgbClr val="D9CCEB"/>
+            </a:solidFill>
+          </a:ln>
+          <a:effectLst/>
+        </p:spPr>
+        <p:style>
+          <a:lnRef idx="1">
+            <a:schemeClr val="accent1"/>
+          </a:lnRef>
+          <a:fillRef idx="3">
+            <a:schemeClr val="accent1"/>
+          </a:fillRef>
+          <a:effectRef idx="2">
+            <a:schemeClr val="accent1"/>
+          </a:effectRef>
+          <a:fontRef idx="minor">
+            <a:schemeClr val="lt1"/>
+          </a:fontRef>
+        </p:style>
+        <p:txBody>
+          <a:bodyPr rtlCol="0" anchor="ctr" wrap="square" lIns="64008" rIns="64008" tIns="36576" bIns="36576"/>
+          <a:lstStyle/>
+          <a:p>
+            <a:pPr algn="l"/>
+            <a:r>
+              <a:rPr sz="850" b="1">
+                <a:solidFill>
+                  <a:srgbClr val="4F2D7F"/>
+                </a:solidFill>
+                <a:latin typeface="Arial"/>
+              </a:rPr>
+              <a:t>Client: </a:t>
+            </a:r>
+            <a:r>
+              <a:rPr sz="850" b="0">
+                <a:solidFill>
+                  <a:srgbClr val="4F2D7F"/>
+                </a:solidFill>
+                <a:latin typeface="Arial"/>
+              </a:rPr>
+              <a:t>Function heads validate priorities</a:t>
+            </a:r>
+          </a:p>
+        </p:txBody>
+      </p:sp>
+      <p:sp>
+        <p:nvSpPr>
+          <p:cNvPr id="25" name="Rectangle 24"/>
+          <p:cNvSpPr/>
+          <p:nvPr/>
+        </p:nvSpPr>
+        <p:spPr>
+          <a:xfrm>
+            <a:off x="6195938" y="4150000"/>
+            <a:ext cx="1810514" cy="520000"/>
+          </a:xfrm>
+          <a:prstGeom prst="rect">
+            <a:avLst/>
+          </a:prstGeom>
+          <a:solidFill>
+            <a:srgbClr val="D9CCEB"/>
+          </a:solidFill>
+          <a:ln>
+            <a:noFill/>
+          </a:ln>
+          <a:effectLst/>
+        </p:spPr>
+        <p:style>
+          <a:lnRef idx="1">
+            <a:schemeClr val="accent1"/>
+          </a:lnRef>
+          <a:fillRef idx="3">
+            <a:schemeClr val="accent1"/>
+          </a:fillRef>
+          <a:effectRef idx="2">
+            <a:schemeClr val="accent1"/>
+          </a:effectRef>
+          <a:fontRef idx="minor">
+            <a:schemeClr val="lt1"/>
+          </a:fontRef>
+        </p:style>
+        <p:txBody>
+          <a:bodyPr rtlCol="0" anchor="ctr" wrap="square" lIns="64008" rIns="64008" tIns="36576" bIns="36576"/>
+          <a:lstStyle/>
+          <a:p>
+            <a:pPr algn="l"/>
+            <a:r>
+              <a:rPr sz="900" b="1">
+                <a:solidFill>
+                  <a:srgbClr val="4F2D7F"/>
+                </a:solidFill>
+                <a:latin typeface="Arial"/>
+              </a:rPr>
+              <a:t>Output: </a:t>
+            </a:r>
+            <a:r>
+              <a:rPr sz="900" b="0">
+                <a:solidFill>
+                  <a:srgbClr val="4F2D7F"/>
+                </a:solidFill>
+                <a:latin typeface="Arial"/>
+              </a:rPr>
+              <a:t>Prioritised portfolio &amp; business case</a:t>
+            </a:r>
+          </a:p>
+        </p:txBody>
+      </p:sp>
+      <p:sp>
+        <p:nvSpPr>
+          <p:cNvPr id="26" name="Rectangle 25"/>
+          <p:cNvSpPr/>
+          <p:nvPr/>
+        </p:nvSpPr>
+        <p:spPr>
+          <a:xfrm>
+            <a:off x="8086452" y="1360000"/>
+            <a:ext cx="1810514" cy="560000"/>
+          </a:xfrm>
+          <a:prstGeom prst="rect">
+            <a:avLst/>
+          </a:prstGeom>
+          <a:solidFill>
+            <a:srgbClr val="E8705F"/>
+          </a:solidFill>
+          <a:ln>
+            <a:noFill/>
+          </a:ln>
+          <a:effectLst/>
+        </p:spPr>
+        <p:style>
+          <a:lnRef idx="1">
+            <a:schemeClr val="accent1"/>
+          </a:lnRef>
+          <a:fillRef idx="3">
+            <a:schemeClr val="accent1"/>
+          </a:fillRef>
+          <a:effectRef idx="2">
+            <a:schemeClr val="accent1"/>
+          </a:effectRef>
+          <a:fontRef idx="minor">
+            <a:schemeClr val="lt1"/>
+          </a:fontRef>
+        </p:style>
+        <p:txBody>
+          <a:bodyPr rtlCol="0" anchor="ctr" wrap="square" lIns="64008" rIns="64008" tIns="36576" bIns="36576"/>
+          <a:lstStyle/>
+          <a:p>
+            <a:pPr algn="ctr"/>
+            <a:r>
+              <a:rPr sz="1100" b="1">
+                <a:solidFill>
+                  <a:srgbClr val="FFFFFF"/>
+                </a:solidFill>
+                <a:latin typeface="Arial"/>
+              </a:rPr>
+              <a:t>5  </a:t>
+            </a:r>
+            <a:r>
+              <a:rPr sz="1100" b="1">
+                <a:solidFill>
+                  <a:srgbClr val="FFFFFF"/>
+                </a:solidFill>
+                <a:latin typeface="Arial"/>
+              </a:rPr>
+              <a:t>Set guardrails &amp; operating model</a:t>
+            </a:r>
+          </a:p>
+        </p:txBody>
+      </p:sp>
+      <p:sp>
+        <p:nvSpPr>
+          <p:cNvPr id="27" name="Rectangle 26"/>
+          <p:cNvSpPr/>
+          <p:nvPr/>
+        </p:nvSpPr>
+        <p:spPr>
+          <a:xfrm>
+            <a:off x="8086452" y="1920000"/>
+            <a:ext cx="1810514" cy="1650000"/>
+          </a:xfrm>
+          <a:prstGeom prst="rect">
+            <a:avLst/>
+          </a:prstGeom>
+          <a:solidFill>
+            <a:srgbClr val="EDE7F6"/>
+          </a:solidFill>
+          <a:ln>
+            <a:noFill/>
+          </a:ln>
+          <a:effectLst/>
+        </p:spPr>
+        <p:style>
+          <a:lnRef idx="1">
+            <a:schemeClr val="accent1"/>
+          </a:lnRef>
+          <a:fillRef idx="3">
+            <a:schemeClr val="accent1"/>
+          </a:fillRef>
+          <a:effectRef idx="2">
+            <a:schemeClr val="accent1"/>
+          </a:effectRef>
+          <a:fontRef idx="minor">
+            <a:schemeClr val="lt1"/>
+          </a:fontRef>
+        </p:style>
+        <p:txBody>
+          <a:bodyPr rtlCol="0" anchor="t" wrap="square" lIns="64008" rIns="64008" tIns="36576" bIns="36576"/>
+          <a:lstStyle/>
+          <a:p>
+            <a:pPr algn="l"/>
+            <a:r>
+              <a:rPr sz="950" b="0">
+                <a:solidFill>
+                  <a:srgbClr val="222222"/>
+                </a:solidFill>
+                <a:latin typeface="Arial"/>
+              </a:rPr>
+              <a:t>Risk appetite, approval by risk tier (GT AI Risk Assessment Framework), sponsor, AI owner / CoE, intake and stage-gates.</a:t>
+            </a:r>
+          </a:p>
+        </p:txBody>
+      </p:sp>
+      <p:sp>
+        <p:nvSpPr>
+          <p:cNvPr id="28" name="Rectangle 27"/>
+          <p:cNvSpPr/>
+          <p:nvPr/>
+        </p:nvSpPr>
+        <p:spPr>
+          <a:xfrm>
+            <a:off x="8086452" y="3600000"/>
+            <a:ext cx="1810514" cy="520000"/>
+          </a:xfrm>
+          <a:prstGeom prst="rect">
+            <a:avLst/>
+          </a:prstGeom>
+          <a:solidFill>
+            <a:srgbClr val="FFFFFF"/>
+          </a:solidFill>
+          <a:ln w="12700">
+            <a:solidFill>
+              <a:srgbClr val="D9CCEB"/>
+            </a:solidFill>
+          </a:ln>
+          <a:effectLst/>
+        </p:spPr>
+        <p:style>
+          <a:lnRef idx="1">
+            <a:schemeClr val="accent1"/>
+          </a:lnRef>
+          <a:fillRef idx="3">
+            <a:schemeClr val="accent1"/>
+          </a:fillRef>
+          <a:effectRef idx="2">
+            <a:schemeClr val="accent1"/>
+          </a:effectRef>
+          <a:fontRef idx="minor">
+            <a:schemeClr val="lt1"/>
+          </a:fontRef>
+        </p:style>
+        <p:txBody>
+          <a:bodyPr rtlCol="0" anchor="ctr" wrap="square" lIns="64008" rIns="64008" tIns="36576" bIns="36576"/>
+          <a:lstStyle/>
+          <a:p>
+            <a:pPr algn="l"/>
+            <a:r>
+              <a:rPr sz="850" b="1">
+                <a:solidFill>
+                  <a:srgbClr val="4F2D7F"/>
+                </a:solidFill>
+                <a:latin typeface="Arial"/>
+              </a:rPr>
+              <a:t>Client: </a:t>
+            </a:r>
+            <a:r>
+              <a:rPr sz="850" b="0">
+                <a:solidFill>
+                  <a:srgbClr val="4F2D7F"/>
+                </a:solidFill>
+                <a:latin typeface="Arial"/>
+              </a:rPr>
+              <a:t>Risk, IT and compliance input</a:t>
+            </a:r>
+          </a:p>
+        </p:txBody>
+      </p:sp>
+      <p:sp>
+        <p:nvSpPr>
+          <p:cNvPr id="29" name="Rectangle 28"/>
+          <p:cNvSpPr/>
+          <p:nvPr/>
+        </p:nvSpPr>
+        <p:spPr>
+          <a:xfrm>
+            <a:off x="8086452" y="4150000"/>
+            <a:ext cx="1810514" cy="520000"/>
+          </a:xfrm>
+          <a:prstGeom prst="rect">
+            <a:avLst/>
+          </a:prstGeom>
+          <a:solidFill>
+            <a:srgbClr val="D9CCEB"/>
+          </a:solidFill>
+          <a:ln>
+            <a:noFill/>
+          </a:ln>
+          <a:effectLst/>
+        </p:spPr>
+        <p:style>
+          <a:lnRef idx="1">
+            <a:schemeClr val="accent1"/>
+          </a:lnRef>
+          <a:fillRef idx="3">
+            <a:schemeClr val="accent1"/>
+          </a:fillRef>
+          <a:effectRef idx="2">
+            <a:schemeClr val="accent1"/>
+          </a:effectRef>
+          <a:fontRef idx="minor">
+            <a:schemeClr val="lt1"/>
+          </a:fontRef>
+        </p:style>
+        <p:txBody>
+          <a:bodyPr rtlCol="0" anchor="ctr" wrap="square" lIns="64008" rIns="64008" tIns="36576" bIns="36576"/>
+          <a:lstStyle/>
+          <a:p>
+            <a:pPr algn="l"/>
+            <a:r>
+              <a:rPr sz="900" b="1">
+                <a:solidFill>
+                  <a:srgbClr val="4F2D7F"/>
+                </a:solidFill>
+                <a:latin typeface="Arial"/>
+              </a:rPr>
+              <a:t>Output: </a:t>
+            </a:r>
+            <a:r>
+              <a:rPr sz="900" b="0">
+                <a:solidFill>
+                  <a:srgbClr val="4F2D7F"/>
+                </a:solidFill>
+                <a:latin typeface="Arial"/>
+              </a:rPr>
+              <a:t>Risk appetite &amp; operating model</a:t>
+            </a:r>
+          </a:p>
+        </p:txBody>
+      </p:sp>
+      <p:sp>
+        <p:nvSpPr>
+          <p:cNvPr id="30" name="Rectangle 29"/>
+          <p:cNvSpPr/>
+          <p:nvPr/>
+        </p:nvSpPr>
+        <p:spPr>
+          <a:xfrm>
+            <a:off x="9976966" y="1360000"/>
+            <a:ext cx="1810514" cy="560000"/>
+          </a:xfrm>
+          <a:prstGeom prst="rect">
+            <a:avLst/>
+          </a:prstGeom>
+          <a:solidFill>
+            <a:srgbClr val="5BA85B"/>
+          </a:solidFill>
+          <a:ln>
+            <a:noFill/>
+          </a:ln>
+          <a:effectLst/>
+        </p:spPr>
+        <p:style>
+          <a:lnRef idx="1">
+            <a:schemeClr val="accent1"/>
+          </a:lnRef>
+          <a:fillRef idx="3">
+            <a:schemeClr val="accent1"/>
+          </a:fillRef>
+          <a:effectRef idx="2">
+            <a:schemeClr val="accent1"/>
+          </a:effectRef>
+          <a:fontRef idx="minor">
+            <a:schemeClr val="lt1"/>
+          </a:fontRef>
+        </p:style>
+        <p:txBody>
+          <a:bodyPr rtlCol="0" anchor="ctr" wrap="square" lIns="64008" rIns="64008" tIns="36576" bIns="36576"/>
+          <a:lstStyle/>
+          <a:p>
+            <a:pPr algn="ctr"/>
+            <a:r>
+              <a:rPr sz="1100" b="1">
+                <a:solidFill>
+                  <a:srgbClr val="FFFFFF"/>
+                </a:solidFill>
+                <a:latin typeface="Arial"/>
+              </a:rPr>
+              <a:t>6  </a:t>
+            </a:r>
+            <a:r>
+              <a:rPr sz="1100" b="1">
+                <a:solidFill>
+                  <a:srgbClr val="FFFFFF"/>
+                </a:solidFill>
+                <a:latin typeface="Arial"/>
+              </a:rPr>
+              <a:t>Validate &amp; sign off</a:t>
+            </a:r>
+          </a:p>
+        </p:txBody>
+      </p:sp>
+      <p:sp>
+        <p:nvSpPr>
+          <p:cNvPr id="31" name="Rectangle 30"/>
+          <p:cNvSpPr/>
+          <p:nvPr/>
+        </p:nvSpPr>
+        <p:spPr>
+          <a:xfrm>
+            <a:off x="9976966" y="1920000"/>
+            <a:ext cx="1810514" cy="1650000"/>
+          </a:xfrm>
+          <a:prstGeom prst="rect">
+            <a:avLst/>
+          </a:prstGeom>
+          <a:solidFill>
+            <a:srgbClr val="EDE7F6"/>
+          </a:solidFill>
+          <a:ln>
+            <a:noFill/>
+          </a:ln>
+          <a:effectLst/>
+        </p:spPr>
+        <p:style>
+          <a:lnRef idx="1">
+            <a:schemeClr val="accent1"/>
+          </a:lnRef>
+          <a:fillRef idx="3">
+            <a:schemeClr val="accent1"/>
+          </a:fillRef>
+          <a:effectRef idx="2">
+            <a:schemeClr val="accent1"/>
+          </a:effectRef>
+          <a:fontRef idx="minor">
+            <a:schemeClr val="lt1"/>
+          </a:fontRef>
+        </p:style>
+        <p:txBody>
+          <a:bodyPr rtlCol="0" anchor="t" wrap="square" lIns="64008" rIns="64008" tIns="36576" bIns="36576"/>
+          <a:lstStyle/>
+          <a:p>
+            <a:pPr algn="l"/>
+            <a:r>
+              <a:rPr sz="950" b="0">
+                <a:solidFill>
+                  <a:srgbClr val="222222"/>
+                </a:solidFill>
+                <a:latin typeface="Arial"/>
+              </a:rPr>
+              <a:t>Test against capacity, data foundations and readiness gaps; align with budget; present on Day 5 for approval.</a:t>
+            </a:r>
+          </a:p>
+        </p:txBody>
+      </p:sp>
+      <p:sp>
+        <p:nvSpPr>
+          <p:cNvPr id="32" name="Rectangle 31"/>
+          <p:cNvSpPr/>
+          <p:nvPr/>
+        </p:nvSpPr>
+        <p:spPr>
+          <a:xfrm>
+            <a:off x="9976966" y="3600000"/>
+            <a:ext cx="1810514" cy="520000"/>
+          </a:xfrm>
+          <a:prstGeom prst="rect">
+            <a:avLst/>
+          </a:prstGeom>
+          <a:solidFill>
+            <a:srgbClr val="FFFFFF"/>
+          </a:solidFill>
+          <a:ln w="12700">
+            <a:solidFill>
+              <a:srgbClr val="D9CCEB"/>
+            </a:solidFill>
+          </a:ln>
+          <a:effectLst/>
+        </p:spPr>
+        <p:style>
+          <a:lnRef idx="1">
+            <a:schemeClr val="accent1"/>
+          </a:lnRef>
+          <a:fillRef idx="3">
+            <a:schemeClr val="accent1"/>
+          </a:fillRef>
+          <a:effectRef idx="2">
+            <a:schemeClr val="accent1"/>
+          </a:effectRef>
+          <a:fontRef idx="minor">
+            <a:schemeClr val="lt1"/>
+          </a:fontRef>
+        </p:style>
+        <p:txBody>
+          <a:bodyPr rtlCol="0" anchor="ctr" wrap="square" lIns="64008" rIns="64008" tIns="36576" bIns="36576"/>
+          <a:lstStyle/>
+          <a:p>
+            <a:pPr algn="l"/>
+            <a:r>
+              <a:rPr sz="850" b="1">
+                <a:solidFill>
+                  <a:srgbClr val="4F2D7F"/>
+                </a:solidFill>
+                <a:latin typeface="Arial"/>
+              </a:rPr>
+              <a:t>Client: </a:t>
+            </a:r>
+            <a:r>
+              <a:rPr sz="850" b="0">
+                <a:solidFill>
+                  <a:srgbClr val="4F2D7F"/>
+                </a:solidFill>
+                <a:latin typeface="Arial"/>
+              </a:rPr>
+              <a:t>Leadership presentation (Day 5)</a:t>
+            </a:r>
+          </a:p>
+        </p:txBody>
+      </p:sp>
+      <p:sp>
+        <p:nvSpPr>
+          <p:cNvPr id="33" name="Rectangle 32"/>
+          <p:cNvSpPr/>
+          <p:nvPr/>
+        </p:nvSpPr>
+        <p:spPr>
+          <a:xfrm>
+            <a:off x="9976966" y="4150000"/>
+            <a:ext cx="1810514" cy="520000"/>
+          </a:xfrm>
+          <a:prstGeom prst="rect">
+            <a:avLst/>
+          </a:prstGeom>
+          <a:solidFill>
+            <a:srgbClr val="D9CCEB"/>
+          </a:solidFill>
+          <a:ln>
+            <a:noFill/>
+          </a:ln>
+          <a:effectLst/>
+        </p:spPr>
+        <p:style>
+          <a:lnRef idx="1">
+            <a:schemeClr val="accent1"/>
+          </a:lnRef>
+          <a:fillRef idx="3">
+            <a:schemeClr val="accent1"/>
+          </a:fillRef>
+          <a:effectRef idx="2">
+            <a:schemeClr val="accent1"/>
+          </a:effectRef>
+          <a:fontRef idx="minor">
+            <a:schemeClr val="lt1"/>
+          </a:fontRef>
+        </p:style>
+        <p:txBody>
+          <a:bodyPr rtlCol="0" anchor="ctr" wrap="square" lIns="64008" rIns="64008" tIns="36576" bIns="36576"/>
+          <a:lstStyle/>
+          <a:p>
+            <a:pPr algn="l"/>
+            <a:r>
+              <a:rPr sz="900" b="1">
+                <a:solidFill>
+                  <a:srgbClr val="4F2D7F"/>
+                </a:solidFill>
+                <a:latin typeface="Arial"/>
+              </a:rPr>
+              <a:t>Output: </a:t>
+            </a:r>
+            <a:r>
+              <a:rPr sz="900" b="0">
+                <a:solidFill>
+                  <a:srgbClr val="4F2D7F"/>
+                </a:solidFill>
+                <a:latin typeface="Arial"/>
+              </a:rPr>
+              <a:t>Strategy on a page &amp; roadmap</a:t>
+            </a:r>
+          </a:p>
+        </p:txBody>
+      </p:sp>
+      <p:sp>
+        <p:nvSpPr>
+          <p:cNvPr id="34" name="Rectangle 33"/>
+          <p:cNvSpPr/>
+          <p:nvPr/>
+        </p:nvSpPr>
+        <p:spPr>
+          <a:xfrm>
+            <a:off x="524396" y="4810000"/>
+            <a:ext cx="11263086" cy="330000"/>
+          </a:xfrm>
+          <a:prstGeom prst="rect">
+            <a:avLst/>
+          </a:prstGeom>
+          <a:solidFill>
+            <a:srgbClr val="2E1A47"/>
+          </a:solidFill>
+          <a:ln>
+            <a:noFill/>
+          </a:ln>
+          <a:effectLst/>
+        </p:spPr>
+        <p:style>
+          <a:lnRef idx="1">
+            <a:schemeClr val="accent1"/>
+          </a:lnRef>
+          <a:fillRef idx="3">
+            <a:schemeClr val="accent1"/>
+          </a:fillRef>
+          <a:effectRef idx="2">
+            <a:schemeClr val="accent1"/>
+          </a:effectRef>
+          <a:fontRef idx="minor">
+            <a:schemeClr val="lt1"/>
+          </a:fontRef>
+        </p:style>
+        <p:txBody>
+          <a:bodyPr rtlCol="0" anchor="ctr" wrap="square" lIns="64008" rIns="64008" tIns="36576" bIns="36576"/>
+          <a:lstStyle/>
+          <a:p>
+            <a:pPr algn="l"/>
+            <a:r>
+              <a:rPr sz="1100" b="1">
+                <a:solidFill>
+                  <a:srgbClr val="FFFFFF"/>
+                </a:solidFill>
+                <a:latin typeface="Arial"/>
+              </a:rPr>
+              <a:t>THE RESULT: YOUR AI STRATEGY ON A PAGE</a:t>
+            </a:r>
+          </a:p>
+        </p:txBody>
+      </p:sp>
+      <p:sp>
+        <p:nvSpPr>
+          <p:cNvPr id="35" name="Rectangle 34"/>
+          <p:cNvSpPr/>
+          <p:nvPr/>
+        </p:nvSpPr>
+        <p:spPr>
+          <a:xfrm>
+            <a:off x="524396" y="5200000"/>
+            <a:ext cx="2188617" cy="760000"/>
+          </a:xfrm>
+          <a:prstGeom prst="rect">
+            <a:avLst/>
+          </a:prstGeom>
+          <a:solidFill>
+            <a:srgbClr val="FFFFFF"/>
+          </a:solidFill>
+          <a:ln w="12700">
+            <a:solidFill>
+              <a:srgbClr val="4F2D7F"/>
+            </a:solidFill>
+          </a:ln>
+          <a:effectLst/>
+        </p:spPr>
+        <p:style>
+          <a:lnRef idx="1">
+            <a:schemeClr val="accent1"/>
+          </a:lnRef>
+          <a:fillRef idx="3">
+            <a:schemeClr val="accent1"/>
+          </a:fillRef>
+          <a:effectRef idx="2">
+            <a:schemeClr val="accent1"/>
+          </a:effectRef>
+          <a:fontRef idx="minor">
+            <a:schemeClr val="lt1"/>
+          </a:fontRef>
+        </p:style>
+        <p:txBody>
+          <a:bodyPr rtlCol="0" anchor="ctr" wrap="square" lIns="64008" rIns="64008" tIns="36576" bIns="36576"/>
+          <a:lstStyle/>
+          <a:p>
+            <a:pPr algn="ctr"/>
+            <a:r>
+              <a:rPr sz="1000" b="1">
+                <a:solidFill>
+                  <a:srgbClr val="4F2D7F"/>
+                </a:solidFill>
+                <a:latin typeface="Arial"/>
+              </a:rPr>
+              <a:t>Vision &amp; ambition</a:t>
+            </a:r>
+          </a:p>
+          <a:p>
+            <a:pPr algn="ctr"/>
+            <a:r>
+              <a:rPr sz="1000" b="0">
+                <a:solidFill>
+                  <a:srgbClr val="4F2D7F"/>
+                </a:solidFill>
+                <a:latin typeface="Arial"/>
+              </a:rPr>
+              <a:t>where AI will and will not be used</a:t>
+            </a:r>
+          </a:p>
+        </p:txBody>
+      </p:sp>
+      <p:sp>
+        <p:nvSpPr>
+          <p:cNvPr id="36" name="Rectangle 35"/>
+          <p:cNvSpPr/>
+          <p:nvPr/>
+        </p:nvSpPr>
+        <p:spPr>
+          <a:xfrm>
+            <a:off x="2793013" y="5200000"/>
+            <a:ext cx="2188617" cy="760000"/>
+          </a:xfrm>
+          <a:prstGeom prst="rect">
+            <a:avLst/>
+          </a:prstGeom>
+          <a:solidFill>
+            <a:srgbClr val="FFFFFF"/>
+          </a:solidFill>
+          <a:ln w="12700">
+            <a:solidFill>
+              <a:srgbClr val="4F2D7F"/>
+            </a:solidFill>
+          </a:ln>
+          <a:effectLst/>
+        </p:spPr>
+        <p:style>
+          <a:lnRef idx="1">
+            <a:schemeClr val="accent1"/>
+          </a:lnRef>
+          <a:fillRef idx="3">
+            <a:schemeClr val="accent1"/>
+          </a:fillRef>
+          <a:effectRef idx="2">
+            <a:schemeClr val="accent1"/>
+          </a:effectRef>
+          <a:fontRef idx="minor">
+            <a:schemeClr val="lt1"/>
+          </a:fontRef>
+        </p:style>
+        <p:txBody>
+          <a:bodyPr rtlCol="0" anchor="ctr" wrap="square" lIns="64008" rIns="64008" tIns="36576" bIns="36576"/>
+          <a:lstStyle/>
+          <a:p>
+            <a:pPr algn="ctr"/>
+            <a:r>
+              <a:rPr sz="1000" b="1">
+                <a:solidFill>
+                  <a:srgbClr val="4F2D7F"/>
+                </a:solidFill>
+                <a:latin typeface="Arial"/>
+              </a:rPr>
+              <a:t>3-5 objectives &amp; KPIs</a:t>
+            </a:r>
+          </a:p>
+          <a:p>
+            <a:pPr algn="ctr"/>
+            <a:r>
+              <a:rPr sz="1000" b="0">
+                <a:solidFill>
+                  <a:srgbClr val="4F2D7F"/>
+                </a:solidFill>
+                <a:latin typeface="Arial"/>
+              </a:rPr>
+              <a:t>measurable targets and owners</a:t>
+            </a:r>
+          </a:p>
+        </p:txBody>
+      </p:sp>
+      <p:sp>
+        <p:nvSpPr>
+          <p:cNvPr id="37" name="Rectangle 36"/>
+          <p:cNvSpPr/>
+          <p:nvPr/>
+        </p:nvSpPr>
+        <p:spPr>
+          <a:xfrm>
+            <a:off x="5061630" y="5200000"/>
+            <a:ext cx="2188617" cy="760000"/>
+          </a:xfrm>
+          <a:prstGeom prst="rect">
+            <a:avLst/>
+          </a:prstGeom>
+          <a:solidFill>
+            <a:srgbClr val="FFFFFF"/>
+          </a:solidFill>
+          <a:ln w="12700">
+            <a:solidFill>
+              <a:srgbClr val="4F2D7F"/>
+            </a:solidFill>
+          </a:ln>
+          <a:effectLst/>
+        </p:spPr>
+        <p:style>
+          <a:lnRef idx="1">
+            <a:schemeClr val="accent1"/>
+          </a:lnRef>
+          <a:fillRef idx="3">
+            <a:schemeClr val="accent1"/>
+          </a:fillRef>
+          <a:effectRef idx="2">
+            <a:schemeClr val="accent1"/>
+          </a:effectRef>
+          <a:fontRef idx="minor">
+            <a:schemeClr val="lt1"/>
+          </a:fontRef>
+        </p:style>
+        <p:txBody>
+          <a:bodyPr rtlCol="0" anchor="ctr" wrap="square" lIns="64008" rIns="64008" tIns="36576" bIns="36576"/>
+          <a:lstStyle/>
+          <a:p>
+            <a:pPr algn="ctr"/>
+            <a:r>
+              <a:rPr sz="1000" b="1">
+                <a:solidFill>
+                  <a:srgbClr val="4F2D7F"/>
+                </a:solidFill>
+                <a:latin typeface="Arial"/>
+              </a:rPr>
+              <a:t>Priority themes</a:t>
+            </a:r>
+          </a:p>
+          <a:p>
+            <a:pPr algn="ctr"/>
+            <a:r>
+              <a:rPr sz="1000" b="0">
+                <a:solidFill>
+                  <a:srgbClr val="4F2D7F"/>
+                </a:solidFill>
+                <a:latin typeface="Arial"/>
+              </a:rPr>
+              <a:t>automation programme + AI programme</a:t>
+            </a:r>
+          </a:p>
+        </p:txBody>
+      </p:sp>
+      <p:sp>
+        <p:nvSpPr>
+          <p:cNvPr id="38" name="Rectangle 37"/>
+          <p:cNvSpPr/>
+          <p:nvPr/>
+        </p:nvSpPr>
+        <p:spPr>
+          <a:xfrm>
+            <a:off x="7330247" y="5200000"/>
+            <a:ext cx="2188617" cy="760000"/>
+          </a:xfrm>
+          <a:prstGeom prst="rect">
+            <a:avLst/>
+          </a:prstGeom>
+          <a:solidFill>
+            <a:srgbClr val="FFFFFF"/>
+          </a:solidFill>
+          <a:ln w="12700">
+            <a:solidFill>
+              <a:srgbClr val="4F2D7F"/>
+            </a:solidFill>
+          </a:ln>
+          <a:effectLst/>
+        </p:spPr>
+        <p:style>
+          <a:lnRef idx="1">
+            <a:schemeClr val="accent1"/>
+          </a:lnRef>
+          <a:fillRef idx="3">
+            <a:schemeClr val="accent1"/>
+          </a:fillRef>
+          <a:effectRef idx="2">
+            <a:schemeClr val="accent1"/>
+          </a:effectRef>
+          <a:fontRef idx="minor">
+            <a:schemeClr val="lt1"/>
+          </a:fontRef>
+        </p:style>
+        <p:txBody>
+          <a:bodyPr rtlCol="0" anchor="ctr" wrap="square" lIns="64008" rIns="64008" tIns="36576" bIns="36576"/>
+          <a:lstStyle/>
+          <a:p>
+            <a:pPr algn="ctr"/>
+            <a:r>
+              <a:rPr sz="1000" b="1">
+                <a:solidFill>
+                  <a:srgbClr val="4F2D7F"/>
+                </a:solidFill>
+                <a:latin typeface="Arial"/>
+              </a:rPr>
+              <a:t>Enablers</a:t>
+            </a:r>
+          </a:p>
+          <a:p>
+            <a:pPr algn="ctr"/>
+            <a:r>
+              <a:rPr sz="1000" b="0">
+                <a:solidFill>
+                  <a:srgbClr val="4F2D7F"/>
+                </a:solidFill>
+                <a:latin typeface="Arial"/>
+              </a:rPr>
+              <a:t>data, platforms, people &amp; change</a:t>
+            </a:r>
+          </a:p>
+        </p:txBody>
+      </p:sp>
+      <p:sp>
+        <p:nvSpPr>
+          <p:cNvPr id="39" name="Rectangle 38"/>
+          <p:cNvSpPr/>
+          <p:nvPr/>
+        </p:nvSpPr>
+        <p:spPr>
+          <a:xfrm>
+            <a:off x="9598864" y="5200000"/>
+            <a:ext cx="2188617" cy="760000"/>
+          </a:xfrm>
+          <a:prstGeom prst="rect">
+            <a:avLst/>
+          </a:prstGeom>
+          <a:solidFill>
+            <a:srgbClr val="FFFFFF"/>
+          </a:solidFill>
+          <a:ln w="12700">
+            <a:solidFill>
+              <a:srgbClr val="4F2D7F"/>
+            </a:solidFill>
+          </a:ln>
+          <a:effectLst/>
+        </p:spPr>
+        <p:style>
+          <a:lnRef idx="1">
+            <a:schemeClr val="accent1"/>
+          </a:lnRef>
+          <a:fillRef idx="3">
+            <a:schemeClr val="accent1"/>
+          </a:fillRef>
+          <a:effectRef idx="2">
+            <a:schemeClr val="accent1"/>
+          </a:effectRef>
+          <a:fontRef idx="minor">
+            <a:schemeClr val="lt1"/>
+          </a:fontRef>
+        </p:style>
+        <p:txBody>
+          <a:bodyPr rtlCol="0" anchor="ctr" wrap="square" lIns="64008" rIns="64008" tIns="36576" bIns="36576"/>
+          <a:lstStyle/>
+          <a:p>
+            <a:pPr algn="ctr"/>
+            <a:r>
+              <a:rPr sz="1000" b="1">
+                <a:solidFill>
+                  <a:srgbClr val="4F2D7F"/>
+                </a:solidFill>
+                <a:latin typeface="Arial"/>
+              </a:rPr>
+              <a:t>Guardrails</a:t>
+            </a:r>
+          </a:p>
+          <a:p>
+            <a:pPr algn="ctr"/>
+            <a:r>
+              <a:rPr sz="1000" b="0">
+                <a:solidFill>
+                  <a:srgbClr val="4F2D7F"/>
+                </a:solidFill>
+                <a:latin typeface="Arial"/>
+              </a:rPr>
+              <a:t>risk appetite, approval by tier, operating model</a:t>
             </a:r>
           </a:p>
         </p:txBody>

</xml_diff>